<commit_message>
Credit Benjamin as presentation creator
</commit_message>
<xml_diff>
--- a/presentacion/Cesar_CESA_vision_y_prototipo_v9.pptx
+++ b/presentacion/Cesar_CESA_vision_y_prototipo_v9.pptx
@@ -2,33 +2,33 @@
 <file path=ppt/presentation.xml><?xml version="1.0" encoding="utf-8"?>
 <p:presentation xmlns:p="http://schemas.openxmlformats.org/presentationml/2006/main">
   <p:sldMasterIdLst>
-    <p:sldMasterId xmlns:r="http://schemas.openxmlformats.org/officeDocument/2006/relationships" id="2147483648" r:id="R538817930ac14c4d"/>
+    <p:sldMasterId xmlns:r="http://schemas.openxmlformats.org/officeDocument/2006/relationships" id="2147483648" r:id="R6a13c23630ab4b35"/>
   </p:sldMasterIdLst>
   <p:notesMasterIdLst>
-    <p:notesMasterId xmlns:r="http://schemas.openxmlformats.org/officeDocument/2006/relationships" r:id="Rc8f47be2e8c542b3"/>
+    <p:notesMasterId xmlns:r="http://schemas.openxmlformats.org/officeDocument/2006/relationships" r:id="R313beb89c14d4ac3"/>
   </p:notesMasterIdLst>
   <p:sldIdLst>
-    <p:sldId xmlns:r="http://schemas.openxmlformats.org/officeDocument/2006/relationships" id="256" r:id="Rff1db1a8953e49f3"/>
-    <p:sldId xmlns:r="http://schemas.openxmlformats.org/officeDocument/2006/relationships" id="257" r:id="R9ac1b3847e084554"/>
-    <p:sldId xmlns:r="http://schemas.openxmlformats.org/officeDocument/2006/relationships" id="258" r:id="R58ab47b4840541a7"/>
-    <p:sldId xmlns:r="http://schemas.openxmlformats.org/officeDocument/2006/relationships" id="259" r:id="R6074f382a69449ba"/>
-    <p:sldId xmlns:r="http://schemas.openxmlformats.org/officeDocument/2006/relationships" id="260" r:id="R99dc6b6c68d0494a"/>
-    <p:sldId xmlns:r="http://schemas.openxmlformats.org/officeDocument/2006/relationships" id="261" r:id="R0ee6325a6f564d08"/>
-    <p:sldId xmlns:r="http://schemas.openxmlformats.org/officeDocument/2006/relationships" id="262" r:id="Ra04ceffaea1f464b"/>
-    <p:sldId xmlns:r="http://schemas.openxmlformats.org/officeDocument/2006/relationships" id="263" r:id="R3562c268d9fa4567"/>
-    <p:sldId xmlns:r="http://schemas.openxmlformats.org/officeDocument/2006/relationships" id="264" r:id="R236c0ef293e2463d"/>
-    <p:sldId xmlns:r="http://schemas.openxmlformats.org/officeDocument/2006/relationships" id="265" r:id="R34a60ce3a3a0412c"/>
-    <p:sldId xmlns:r="http://schemas.openxmlformats.org/officeDocument/2006/relationships" id="266" r:id="R81766e139b394b49"/>
-    <p:sldId xmlns:r="http://schemas.openxmlformats.org/officeDocument/2006/relationships" id="267" r:id="Rd2c0cf05d2b349da"/>
-    <p:sldId xmlns:r="http://schemas.openxmlformats.org/officeDocument/2006/relationships" id="268" r:id="Rdbd2af43c3054655"/>
-    <p:sldId xmlns:r="http://schemas.openxmlformats.org/officeDocument/2006/relationships" id="269" r:id="R4e860f0352934e85"/>
-    <p:sldId xmlns:r="http://schemas.openxmlformats.org/officeDocument/2006/relationships" id="270" r:id="R83146e9e7a384a37"/>
-    <p:sldId xmlns:r="http://schemas.openxmlformats.org/officeDocument/2006/relationships" id="271" r:id="R9e6946d2a9834738"/>
-    <p:sldId xmlns:r="http://schemas.openxmlformats.org/officeDocument/2006/relationships" id="272" r:id="Rb48fd05d383047f9"/>
-    <p:sldId xmlns:r="http://schemas.openxmlformats.org/officeDocument/2006/relationships" id="273" r:id="R73fd41f4e0734699"/>
-    <p:sldId xmlns:r="http://schemas.openxmlformats.org/officeDocument/2006/relationships" id="274" r:id="R51311f4e115c42e4"/>
-    <p:sldId xmlns:r="http://schemas.openxmlformats.org/officeDocument/2006/relationships" id="275" r:id="R395ad1099600438a"/>
-    <p:sldId xmlns:r="http://schemas.openxmlformats.org/officeDocument/2006/relationships" id="276" r:id="R8f9064358d0f47c6"/>
+    <p:sldId xmlns:r="http://schemas.openxmlformats.org/officeDocument/2006/relationships" id="256" r:id="R6feb01f6fd0043d6"/>
+    <p:sldId xmlns:r="http://schemas.openxmlformats.org/officeDocument/2006/relationships" id="257" r:id="R4b7d186794124afc"/>
+    <p:sldId xmlns:r="http://schemas.openxmlformats.org/officeDocument/2006/relationships" id="258" r:id="R7040274146ad4a11"/>
+    <p:sldId xmlns:r="http://schemas.openxmlformats.org/officeDocument/2006/relationships" id="259" r:id="R69b8fe1a08b1423b"/>
+    <p:sldId xmlns:r="http://schemas.openxmlformats.org/officeDocument/2006/relationships" id="260" r:id="Rf78b8e5678ac4ac0"/>
+    <p:sldId xmlns:r="http://schemas.openxmlformats.org/officeDocument/2006/relationships" id="261" r:id="R93b189bb29684d9b"/>
+    <p:sldId xmlns:r="http://schemas.openxmlformats.org/officeDocument/2006/relationships" id="262" r:id="R4402dd23ec154e12"/>
+    <p:sldId xmlns:r="http://schemas.openxmlformats.org/officeDocument/2006/relationships" id="263" r:id="Rfe8b22aa52c6491b"/>
+    <p:sldId xmlns:r="http://schemas.openxmlformats.org/officeDocument/2006/relationships" id="264" r:id="Rfe072269f6a444cb"/>
+    <p:sldId xmlns:r="http://schemas.openxmlformats.org/officeDocument/2006/relationships" id="265" r:id="R1f041489a3764baa"/>
+    <p:sldId xmlns:r="http://schemas.openxmlformats.org/officeDocument/2006/relationships" id="266" r:id="R5ba457b350ad459e"/>
+    <p:sldId xmlns:r="http://schemas.openxmlformats.org/officeDocument/2006/relationships" id="267" r:id="Rac55a5af0e0b46c6"/>
+    <p:sldId xmlns:r="http://schemas.openxmlformats.org/officeDocument/2006/relationships" id="268" r:id="Re56a2777edbb47da"/>
+    <p:sldId xmlns:r="http://schemas.openxmlformats.org/officeDocument/2006/relationships" id="269" r:id="Rb125ccae71604dca"/>
+    <p:sldId xmlns:r="http://schemas.openxmlformats.org/officeDocument/2006/relationships" id="270" r:id="R71bf125826244e7c"/>
+    <p:sldId xmlns:r="http://schemas.openxmlformats.org/officeDocument/2006/relationships" id="271" r:id="R25beff262c92415d"/>
+    <p:sldId xmlns:r="http://schemas.openxmlformats.org/officeDocument/2006/relationships" id="272" r:id="Rcb7d85c817d2427d"/>
+    <p:sldId xmlns:r="http://schemas.openxmlformats.org/officeDocument/2006/relationships" id="273" r:id="Rdbc27a46410f45ee"/>
+    <p:sldId xmlns:r="http://schemas.openxmlformats.org/officeDocument/2006/relationships" id="274" r:id="R19e4132058de4046"/>
+    <p:sldId xmlns:r="http://schemas.openxmlformats.org/officeDocument/2006/relationships" id="275" r:id="Reb2fbf5e608d46a6"/>
+    <p:sldId xmlns:r="http://schemas.openxmlformats.org/officeDocument/2006/relationships" id="276" r:id="R91137865f984417e"/>
   </p:sldIdLst>
   <p:sldSz cx="12192000" cy="6858000"/>
   <p:notesSz cx="6858000" cy="9144000"/>
@@ -1302,7 +1302,7 @@
           <a:lstStyle xmlns:a="http://schemas.openxmlformats.org/drawingml/2006/main"/>
           <a:p xmlns:a="http://schemas.openxmlformats.org/drawingml/2006/main">
             <a:r>
-              <a:t>Roles comunicados por el equipo. Juan Zapata realizó pruebas del prototipo. Juan Pablo Salazar asumió la perspectiva de usuario y realizó encuestas a estudiantes y a CESA Contigo para determinar qué implementar y qué descartar. Luis Gutiérrez construyó el chatbot y el contenido del repositorio. Benjamín Herrera apoyó las tareas pendientes; no se especificó un alcance más concreto.</a:t>
+              <a:t>Roles comunicados por el equipo. Juan Zapata realizó pruebas del prototipo. Juan Pablo Salazar asumió la perspectiva de usuario y realizó encuestas a estudiantes y a CESA Contigo para determinar qué implementar y qué descartar. Luis Gutiérrez construyó el chatbot y el contenido del repositorio. Benjamín Herrera creó la presentación.</a:t>
             </a:r>
           </a:p>
         </p:txBody>
@@ -1930,7 +1930,7 @@
   </p:cSld>
   <p:clrMap bg1="lt1" tx1="dk1" bg2="lt2" tx2="dk2" accent1="accent1" accent2="accent2" accent3="accent3" accent4="accent4" accent5="accent5" accent6="accent6" hlink="hlink" folHlink="folHlink"/>
   <p:sldLayoutIdLst>
-    <p:sldLayoutId xmlns:r="http://schemas.openxmlformats.org/officeDocument/2006/relationships" id="2147483649" r:id="Rd99097c947854a4c"/>
+    <p:sldLayoutId xmlns:r="http://schemas.openxmlformats.org/officeDocument/2006/relationships" id="2147483649" r:id="R2f600ada10e34c7d"/>
   </p:sldLayoutIdLst>
   <p:txStyles>
     <p:titleStyle>
@@ -2485,7 +2485,7 @@
           <p:nvPr/>
         </p:nvPicPr>
         <p:blipFill>
-          <a:blip xmlns:r="http://schemas.openxmlformats.org/officeDocument/2006/relationships" xmlns:a="http://schemas.openxmlformats.org/drawingml/2006/main" r:embed="R34ef0c1979834fe3"/>
+          <a:blip xmlns:r="http://schemas.openxmlformats.org/officeDocument/2006/relationships" xmlns:a="http://schemas.openxmlformats.org/drawingml/2006/main" r:embed="R8fc3452595ce44c3"/>
           <a:srcRect xmlns:a="http://schemas.openxmlformats.org/drawingml/2006/main" l="15458" t="0" r="15458" b="0"/>
           <a:stretch xmlns:a="http://schemas.openxmlformats.org/drawingml/2006/main">
             <a:fillRect l="0" t="0" r="0" b="0"/>
@@ -3179,7 +3179,7 @@
           <p:nvPr/>
         </p:nvPicPr>
         <p:blipFill>
-          <a:blip xmlns:r="http://schemas.openxmlformats.org/officeDocument/2006/relationships" xmlns:a="http://schemas.openxmlformats.org/drawingml/2006/main" r:embed="Rab83fe58307f4fae"/>
+          <a:blip xmlns:r="http://schemas.openxmlformats.org/officeDocument/2006/relationships" xmlns:a="http://schemas.openxmlformats.org/drawingml/2006/main" r:embed="Rff47c2281bb54d45"/>
           <a:srcRect xmlns:a="http://schemas.openxmlformats.org/drawingml/2006/main" l="3558" t="0" r="3558" b="0"/>
           <a:stretch xmlns:a="http://schemas.openxmlformats.org/drawingml/2006/main">
             <a:fillRect l="0" t="0" r="0" b="0"/>
@@ -5211,7 +5211,7 @@
           <p:nvPr/>
         </p:nvPicPr>
         <p:blipFill>
-          <a:blip xmlns:r="http://schemas.openxmlformats.org/officeDocument/2006/relationships" xmlns:a="http://schemas.openxmlformats.org/drawingml/2006/main" r:embed="R2978dcce90b2401e"/>
+          <a:blip xmlns:r="http://schemas.openxmlformats.org/officeDocument/2006/relationships" xmlns:a="http://schemas.openxmlformats.org/drawingml/2006/main" r:embed="R5d2dbd1f22d04e59"/>
           <a:stretch xmlns:a="http://schemas.openxmlformats.org/drawingml/2006/main"/>
         </p:blipFill>
         <p:spPr>
@@ -5552,7 +5552,7 @@
           <p:nvPr/>
         </p:nvPicPr>
         <p:blipFill>
-          <a:blip xmlns:r="http://schemas.openxmlformats.org/officeDocument/2006/relationships" xmlns:a="http://schemas.openxmlformats.org/drawingml/2006/main" r:embed="R0fbc28f4411243f6"/>
+          <a:blip xmlns:r="http://schemas.openxmlformats.org/officeDocument/2006/relationships" xmlns:a="http://schemas.openxmlformats.org/drawingml/2006/main" r:embed="Rf0c391fabe784ea0"/>
           <a:stretch xmlns:a="http://schemas.openxmlformats.org/drawingml/2006/main"/>
         </p:blipFill>
         <p:spPr>
@@ -5893,7 +5893,7 @@
           <p:nvPr/>
         </p:nvPicPr>
         <p:blipFill>
-          <a:blip xmlns:r="http://schemas.openxmlformats.org/officeDocument/2006/relationships" xmlns:a="http://schemas.openxmlformats.org/drawingml/2006/main" r:embed="Rc1673c94e7a84043"/>
+          <a:blip xmlns:r="http://schemas.openxmlformats.org/officeDocument/2006/relationships" xmlns:a="http://schemas.openxmlformats.org/drawingml/2006/main" r:embed="Rd9517c0ee9044da8"/>
           <a:stretch xmlns:a="http://schemas.openxmlformats.org/drawingml/2006/main"/>
         </p:blipFill>
         <p:spPr>
@@ -6234,7 +6234,7 @@
           <p:nvPr/>
         </p:nvPicPr>
         <p:blipFill>
-          <a:blip xmlns:r="http://schemas.openxmlformats.org/officeDocument/2006/relationships" xmlns:a="http://schemas.openxmlformats.org/drawingml/2006/main" r:embed="R2a1c5a1a9f704e91"/>
+          <a:blip xmlns:r="http://schemas.openxmlformats.org/officeDocument/2006/relationships" xmlns:a="http://schemas.openxmlformats.org/drawingml/2006/main" r:embed="Rcfb0e757ebb24ed1"/>
           <a:stretch xmlns:a="http://schemas.openxmlformats.org/drawingml/2006/main"/>
         </p:blipFill>
         <p:spPr>
@@ -8726,7 +8726,7 @@
           <p:nvPr/>
         </p:nvPicPr>
         <p:blipFill>
-          <a:blip xmlns:r="http://schemas.openxmlformats.org/officeDocument/2006/relationships" xmlns:a="http://schemas.openxmlformats.org/drawingml/2006/main" r:embed="R7b90c20bc1c84d89"/>
+          <a:blip xmlns:r="http://schemas.openxmlformats.org/officeDocument/2006/relationships" xmlns:a="http://schemas.openxmlformats.org/drawingml/2006/main" r:embed="R7ff0ebf1071a4253"/>
           <a:srcRect xmlns:a="http://schemas.openxmlformats.org/drawingml/2006/main" l="0" t="5556" r="0" b="5556"/>
           <a:stretch xmlns:a="http://schemas.openxmlformats.org/drawingml/2006/main">
             <a:fillRect l="0" t="0" r="0" b="0"/>
@@ -9908,7 +9908,7 @@
                 <a:ea typeface="Arial"/>
                 <a:cs typeface="Arial"/>
               </a:rPr>
-              <a:t>Apoyo en tareas pendientes</a:t>
+              <a:t>Creador de la presentación</a:t>
             </a:r>
           </a:p>
         </p:txBody>
@@ -10251,7 +10251,7 @@
           <p:nvPr/>
         </p:nvPicPr>
         <p:blipFill>
-          <a:blip xmlns:r="http://schemas.openxmlformats.org/officeDocument/2006/relationships" xmlns:a="http://schemas.openxmlformats.org/drawingml/2006/main" r:embed="Rd519f5932fbe467b"/>
+          <a:blip xmlns:r="http://schemas.openxmlformats.org/officeDocument/2006/relationships" xmlns:a="http://schemas.openxmlformats.org/drawingml/2006/main" r:embed="R0c8b2e0e9dba4d7c"/>
           <a:stretch xmlns:a="http://schemas.openxmlformats.org/drawingml/2006/main"/>
         </p:blipFill>
         <p:spPr>
@@ -10588,7 +10588,7 @@
           <p:nvPr/>
         </p:nvPicPr>
         <p:blipFill>
-          <a:blip xmlns:r="http://schemas.openxmlformats.org/officeDocument/2006/relationships" xmlns:a="http://schemas.openxmlformats.org/drawingml/2006/main" r:embed="Rfafeb7bac8e349d1"/>
+          <a:blip xmlns:r="http://schemas.openxmlformats.org/officeDocument/2006/relationships" xmlns:a="http://schemas.openxmlformats.org/drawingml/2006/main" r:embed="R45aa5ed4ff044dc2"/>
           <a:srcRect xmlns:a="http://schemas.openxmlformats.org/drawingml/2006/main" l="21019" t="0" r="21019" b="0"/>
           <a:stretch xmlns:a="http://schemas.openxmlformats.org/drawingml/2006/main">
             <a:fillRect l="0" t="0" r="0" b="0"/>
@@ -11597,7 +11597,7 @@
           <p:nvPr/>
         </p:nvPicPr>
         <p:blipFill>
-          <a:blip xmlns:r="http://schemas.openxmlformats.org/officeDocument/2006/relationships" xmlns:a="http://schemas.openxmlformats.org/drawingml/2006/main" r:embed="Rc2296ce679374b48"/>
+          <a:blip xmlns:r="http://schemas.openxmlformats.org/officeDocument/2006/relationships" xmlns:a="http://schemas.openxmlformats.org/drawingml/2006/main" r:embed="Rf8b5774753c047cb"/>
           <a:srcRect xmlns:a="http://schemas.openxmlformats.org/drawingml/2006/main" l="20386" t="0" r="20386" b="0"/>
           <a:stretch xmlns:a="http://schemas.openxmlformats.org/drawingml/2006/main">
             <a:fillRect l="0" t="0" r="0" b="0"/>
@@ -12402,7 +12402,7 @@
           <p:nvPr/>
         </p:nvPicPr>
         <p:blipFill>
-          <a:blip xmlns:r="http://schemas.openxmlformats.org/officeDocument/2006/relationships" xmlns:a="http://schemas.openxmlformats.org/drawingml/2006/main" r:embed="Re7b946fea44c4853"/>
+          <a:blip xmlns:r="http://schemas.openxmlformats.org/officeDocument/2006/relationships" xmlns:a="http://schemas.openxmlformats.org/drawingml/2006/main" r:embed="Rea5dee0e761f4ee3"/>
           <a:srcRect xmlns:a="http://schemas.openxmlformats.org/drawingml/2006/main" l="25926" t="0" r="25926" b="0"/>
           <a:stretch xmlns:a="http://schemas.openxmlformats.org/drawingml/2006/main">
             <a:fillRect l="0" t="0" r="0" b="0"/>

</xml_diff>